<commit_message>
Build submission presentation deck
</commit_message>
<xml_diff>
--- a/presentation/WISER_Vanguard_Quantum_Portfolio_Challenge_2026.pptx
+++ b/presentation/WISER_Vanguard_Quantum_Portfolio_Challenge_2026.pptx
@@ -1898,8 +1898,8 @@
         </p:nvSpPr>
         <p:spPr>
           <a:xfrm>
-            <a:off x="4352544" y="2578608"/>
-            <a:ext cx="6675120" cy="731520"/>
+            <a:off x="4352544" y="2432304"/>
+            <a:ext cx="6675120" cy="274320"/>
           </a:xfrm>
           <a:prstGeom prst="rect">
             <a:avLst/>
@@ -1915,20 +1915,56 @@
               <a:buNone/>
             </a:pPr>
             <a:r>
-              <a:rPr lang="en-US" sz="1700" dirty="0">
+              <a:rPr lang="en-US" sz="1400" b="1" dirty="0">
+                <a:solidFill>
+                  <a:srgbClr val="7B1E35"/>
+                </a:solidFill>
+              </a:rPr>
+              <a:t>Anurag Sarkar  |  Ankit Gill</a:t>
+            </a:r>
+            <a:endParaRPr lang="en-US" sz="1400" dirty="0"/>
+          </a:p>
+        </p:txBody>
+      </p:sp>
+      <p:sp>
+        <p:nvSpPr>
+          <p:cNvPr id="8" name="Text 6"/>
+          <p:cNvSpPr/>
+          <p:nvPr/>
+        </p:nvSpPr>
+        <p:spPr>
+          <a:xfrm>
+            <a:off x="4352544" y="2788920"/>
+            <a:ext cx="6675120" cy="685800"/>
+          </a:xfrm>
+          <a:prstGeom prst="rect">
+            <a:avLst/>
+          </a:prstGeom>
+          <a:noFill/>
+          <a:ln/>
+        </p:spPr>
+        <p:txBody>
+          <a:bodyPr wrap="square" lIns="0" tIns="0" rIns="0" bIns="0" rtlCol="0" anchor="ctr"/>
+          <a:lstStyle/>
+          <a:p>
+            <a:pPr indent="0" marL="0">
+              <a:buNone/>
+            </a:pPr>
+            <a:r>
+              <a:rPr lang="en-US" sz="1650" dirty="0">
                 <a:solidFill>
                   <a:srgbClr val="6B6B72"/>
                 </a:solidFill>
               </a:rPr>
               <a:t>Audited classical optimization + exact QUBO/QAOA benchmark + higher-moment HUBO/VQE research extension</a:t>
             </a:r>
-            <a:endParaRPr lang="en-US" sz="1700" dirty="0"/>
-          </a:p>
-        </p:txBody>
-      </p:sp>
-      <p:sp>
-        <p:nvSpPr>
-          <p:cNvPr id="8" name="Shape 6"/>
+            <a:endParaRPr lang="en-US" sz="1650" dirty="0"/>
+          </a:p>
+        </p:txBody>
+      </p:sp>
+      <p:sp>
+        <p:nvSpPr>
+          <p:cNvPr id="9" name="Shape 7"/>
           <p:cNvSpPr/>
           <p:nvPr/>
         </p:nvSpPr>
@@ -1953,7 +1989,7 @@
       </p:sp>
       <p:sp>
         <p:nvSpPr>
-          <p:cNvPr id="9" name="Text 7"/>
+          <p:cNvPr id="10" name="Text 8"/>
           <p:cNvSpPr/>
           <p:nvPr/>
         </p:nvSpPr>
@@ -1989,7 +2025,7 @@
       </p:sp>
       <p:sp>
         <p:nvSpPr>
-          <p:cNvPr id="10" name="Shape 8"/>
+          <p:cNvPr id="11" name="Shape 9"/>
           <p:cNvSpPr/>
           <p:nvPr/>
         </p:nvSpPr>
@@ -2014,7 +2050,7 @@
       </p:sp>
       <p:sp>
         <p:nvSpPr>
-          <p:cNvPr id="11" name="Text 9"/>
+          <p:cNvPr id="12" name="Text 10"/>
           <p:cNvSpPr/>
           <p:nvPr/>
         </p:nvSpPr>
@@ -2050,7 +2086,7 @@
       </p:sp>
       <p:sp>
         <p:nvSpPr>
-          <p:cNvPr id="12" name="Shape 10"/>
+          <p:cNvPr id="13" name="Shape 11"/>
           <p:cNvSpPr/>
           <p:nvPr/>
         </p:nvSpPr>
@@ -2075,7 +2111,7 @@
       </p:sp>
       <p:sp>
         <p:nvSpPr>
-          <p:cNvPr id="13" name="Text 11"/>
+          <p:cNvPr id="14" name="Text 12"/>
           <p:cNvSpPr/>
           <p:nvPr/>
         </p:nvSpPr>
@@ -2111,7 +2147,7 @@
       </p:sp>
       <p:sp>
         <p:nvSpPr>
-          <p:cNvPr id="14" name="Text 12"/>
+          <p:cNvPr id="15" name="Text 13"/>
           <p:cNvSpPr/>
           <p:nvPr/>
         </p:nvSpPr>
@@ -2147,7 +2183,7 @@
       </p:sp>
       <p:sp>
         <p:nvSpPr>
-          <p:cNvPr id="15" name="Text 13"/>
+          <p:cNvPr id="16" name="Text 14"/>
           <p:cNvSpPr/>
           <p:nvPr/>
         </p:nvSpPr>

</xml_diff>